<commit_message>
TASK-016: add source-grounded figures and data to research report
</commit_message>
<xml_diff>
--- a/presentations/task-010-group-meeting-rebuild/PIC_Harness_Research_首次组会调研_20页.pptx
+++ b/presentations/task-010-group-meeting-rebuild/PIC_Harness_Research_首次组会调研_20页.pptx
@@ -697,7 +697,7 @@
           <a:p>
             <a:r>
               <a:rPr lang="en-US" dirty="0"/>
-              <a:t>单次脚本生成由工程师运行和检查。Agent 方法增加任务状态、工具接口、输出检查及下一步决策；是否真正闭环要看工具调用与验证证据。PICopilot 主要评价脚本输出，AutoPhotonicDesign 展示真实仿真迭代。</a:t>
+              <a:t>此图右侧是 Kharel 等 Fig. 1 和 §2 支持的通用求解器在环路径，不代表 PICopilot 已实现。PICopilot 内部 Script Evaluator 用静态代码检查、自定义检查库和 LLM，benchmark 才在外部执行脚本并比对参考输出；因此其 48/48 不是 Agent 内部电磁仿真迭代证据。Kharel 的 acceptance criteria 由工程师给定。</a:t>
             </a:r>
             <a:endParaRPr lang="en-US" dirty="0"/>
           </a:p>
@@ -873,7 +873,7 @@
           <a:p>
             <a:r>
               <a:rPr lang="en-US" dirty="0"/>
-              <a:t>解释图中四个角色而非只念 Agent 名称。论文以 102 个 prompt 评价流程，作者报告单器件最高约 91%、≤15 元件电路 pass@5 约 57%。FDTD 分支因兼容性没有进入主发布。GDS/DRC 与 SAX 不等于实际器件性能或代工签核。</a:t>
+              <a:t>解释图中四段：interpreter、designer、layout、circuit verification；前两段是 LLM Agent，后两段主要是算法模块。102 个 prompt 中 level 1/2/3/4 为 23/10/60/9，7 模型每题各 5 次。Fig. 5 显示复杂度升高后成功率下降；正文报告单器件最高约 91%、levels 1–3 汇总 pass@5 最高 58%。Table II 的 S 仅要求有效 schematic 与 GDSII。FDTD 分支未进入主发布；结构成功不等于性能达标或 foundry signoff。</a:t>
             </a:r>
             <a:endParaRPr lang="en-US" dirty="0"/>
           </a:p>
@@ -961,7 +961,7 @@
           <a:p>
             <a:r>
               <a:rPr lang="en-US" dirty="0"/>
-              <a:t>图中 PIC Designer 提供任务；Task Planner 分解，Function-specific Script Generator 经手册检索生成代码，Script Synthesizer 汇总，Script Evaluator 做静态与自定义检查。论文的任务是脚本生成，不可把产出的 FDTD 脚本等同已经运行的物理结果。</a:t>
+              <a:t>图中 PIC Designer 提供任务；Task Planner 分解，Function-specific Script Generator 经手册 RAG 生成代码，Script Synthesizer 汇总。§3.6 明确 Script Evaluator 内部用静态代码检查、自定义检查库和 LLM，不直接运行耗时的 PIC 工具。§4.1.4 的 benchmark 另运行脚本，功能结果与参考一致算 trial 成功，至少 3/15 次计 task solved。作者报告 48/48、总 pass@1 93.9%、pass@5 99.9%；都不是物理性能资格验证。本项目未核实公开实现。</a:t>
             </a:r>
             <a:endParaRPr lang="en-US" dirty="0"/>
           </a:p>
@@ -1049,7 +1049,7 @@
           <a:p>
             <a:r>
               <a:rPr lang="en-US" dirty="0"/>
-              <a:t>红叉是被丢弃尝试、绿点是保留结果、绿线是迄今最优。论文展示真实物理求解器输出驱动设计迭代，这是较强的仿真在环证据。但人类工程师准备 design.py/program.md 的目标、约束与 evaluator；多物理调制器例子还需要专家修正。图中横轴 50 experiments 不能直接转化为通用成功率。</a:t>
+              <a:t>红叉为丢弃尝试、绿点为保留结果、绿线为迄今最优。弯曲器件是 400 nm SiN、1550 nm、150 nm 最小特征、12 µm 半径的仿真；50 是预算，最优在第 38 次。Fig. 3 另有 39 次 PN 结迭代、Fig. 5 有 192→0 DRC violations。多物理 MZM 首次在 30 GHz 得到约 15 Ω，参考值 48 Ω；Table S2 记录专家修正 mode 识别及 junction shunt 等设置，之后才进入九设计的自治循环。故不应宣称无条件独立理解物理。</a:t>
             </a:r>
             <a:endParaRPr lang="en-US" dirty="0"/>
           </a:p>
@@ -1137,7 +1137,7 @@
           <a:p>
             <a:r>
               <a:rPr lang="en-US" dirty="0"/>
-              <a:t>矩阵不是全领域支持/不支持判断。PhIDO 验证结构/电路流程；PICopilot 主要为脚本任务；AutoPhotonicDesign 有真实 solver；PICBench 通过 JSON netlist 与 SAX 评价。待核表示本轮论文证据未足以确定。</a:t>
+              <a:t>完整八列比较表在 references/task-016-evidence/agentic-pic-comparison.md。PhIDO 的 S 是有效 schematic/GDSII；PICopilot 的 #Solved 是脚本外部运行后参考输出相符、至少 3/15 次；Kharel 是人类提供规则和定量目标后以求解器数值通过验收。它们不能按 91%、48/48 和器件损耗作单一能力排名。</a:t>
             </a:r>
             <a:endParaRPr lang="en-US" dirty="0"/>
           </a:p>
@@ -1841,7 +1841,7 @@
           <a:p>
             <a:r>
               <a:rPr lang="en-US" dirty="0"/>
-              <a:t>2024 SOI PIC 集成调制、偏振处理、光学混合和平衡探测，激光及采集仍片外。2026 工作进一步把 InP 外腔激光、微光学、SOI PIC 和 TEC 封装在模块中，但并非完整系统片上化。</a:t>
+              <a:t>图依据 Jin 2024 Fig. 1(b) 和 Fig. 3 改绘，不是论文原图。Fig. 5：12.1 km、100 Hz PZT、0.819 m gauge length 下为 1.14 m 与 59 pε/√Hz；Fig. 6：49.0 km、4.01 m gauge length 下为 3.78 m 与 81 pε/√Hz。均为作者报告。窄线宽激光、EDFA、环行器、AWG、TIA、DAQ 和 DSP 仍片外；论文原始数据未公开。Sandmann 2023 Fig. 2/5 另展示通信 IC-TROSA 复用于 20 km 后 200 Hz 声学实验，是不同路线，不能用指标直接比较。</a:t>
             </a:r>
             <a:endParaRPr lang="en-US" dirty="0"/>
           </a:p>
@@ -1929,7 +1929,7 @@
           <a:p>
             <a:r>
               <a:rPr lang="en-US" dirty="0"/>
-              <a:t>原始 PDF 在当前 Zotero 附件中未找到，因此按已核验会议论文与正式报告重绘。模块约 40×40×10 mm，激光线宽低于 3 kHz；作者在 10 km G.652.D 上报告约 4 m 空间分辨率与 73.27 pε/√Hz 特定统计口径应变分辨率。三页论文缺少完整功耗、良率、长期漂移和重复样本数据。</a:t>
+              <a:t>Fig. 1(a) 是四微环结构，(d) 是不同 DC 偏压的原始透射谱，(f) 是脉冲响应。Fig. 2(a) 静态 71 dB、Fig. 2(c) self-heterodyne 动态 68 dB，不能混为一个测量。3.60 mW 是高占空比驱动下 EOM 本体功耗，非全系统。Fig. 4/5 的 2 km Φ-OTDR 台架报告 4 pε/√Hz，与商用 AOM 替换对照。作者指出温漂、硅非线性和约 6.5 ns 响应限制。</a:t>
             </a:r>
             <a:endParaRPr lang="en-US" dirty="0"/>
           </a:p>
@@ -2193,7 +2193,7 @@
           <a:p>
             <a:r>
               <a:rPr lang="en-US" dirty="0"/>
-              <a:t>原图 Fig. 1(b) 是 ACCEL 的 OAC 加模拟电子 EAC。论文在 Fashion-MNIST、三类 ImageNet 和延时视频识别给出任务级实验；作者报告 85.5%、82.0%、92.6% 准确率。性能数字依论文 operation 和系统定义，不能泛化为完整通用 AI 推理。</a:t>
+              <a:t>原论文 Fig. 2(a–c) 把 host、DCI、PTC 和 ABFP 计算链分开。本图是根据原文改绘，不是论文原图。4 个 128×128 PTC 与 2 个 DCI；作者报告 65.5×10¹² ABFP16 ops/s、78 W 电子功率和 1.6 W 光功率。Table 1：ResNet18 CIFAR-10 86.4% 对 FP32 88.3%；BERT-Tiny IMDb 83.2% 对 86.2%，但 SQuAD F1 12.0 对 43.5。ImageWoof 结果经过专门重新训练。主文未给完整统一墙插和各任务能耗；Methods 另列八只激光器每只 1.25 W 电功率。</a:t>
             </a:r>
             <a:endParaRPr lang="en-US" dirty="0"/>
           </a:p>
@@ -2782,7 +2782,7 @@
                 <a:ea typeface="Calibri" pitchFamily="34" charset="-122"/>
                 <a:cs typeface="Calibri" pitchFamily="34" charset="-120"/>
               </a:rPr>
-              <a:t>汇报人：林子涵｜纤维光学与生物光子学课题组｜2026 年 9 月 23 日</a:t>
+              <a:t>汇报人：林子涵｜纤维光学与生物光子学课题组｜2026 年 9 月 29 日（证据增强版）</a:t>
             </a:r>
             <a:endParaRPr lang="en-US" sz="1350" dirty="0"/>
           </a:p>
@@ -3136,7 +3136,7 @@
                 <a:ea typeface="Trebuchet MS" pitchFamily="34" charset="-122"/>
                 <a:cs typeface="Trebuchet MS" pitchFamily="34" charset="-120"/>
               </a:rPr>
-              <a:t>从 LLM 脚本生成到 Agent 工具循环</a:t>
+              <a:t>脚本生成与物理求解器循环的验证层级不同</a:t>
             </a:r>
             <a:endParaRPr lang="en-US" sz="2600" dirty="0"/>
           </a:p>
@@ -3175,7 +3175,7 @@
                 <a:ea typeface="Calibri" pitchFamily="34" charset="-122"/>
                 <a:cs typeface="Calibri" pitchFamily="34" charset="-120"/>
               </a:rPr>
-              <a:t>关键差别是能否读取工具结果并决定下一步</a:t>
+              <a:t>左：生成代码；右：规则闸门、求解器数值、评价与迭代</a:t>
             </a:r>
             <a:endParaRPr lang="en-US" sz="1300" dirty="0"/>
           </a:p>
@@ -3244,7 +3244,7 @@
                 <a:ea typeface="Calibri" pitchFamily="34" charset="-122"/>
                 <a:cs typeface="Calibri" pitchFamily="34" charset="-120"/>
               </a:rPr>
-              <a:t>依据：TASK-005 能力/验证矩阵；PhIDO、PICopilot、AutoPD 原文</a:t>
+              <a:t>依据：PICopilot §3.6/§4.1.4；Kharel §2/Fig. 1</a:t>
             </a:r>
             <a:endParaRPr lang="en-US" sz="1100" dirty="0"/>
           </a:p>
@@ -4061,7 +4061,7 @@
                 <a:ea typeface="Calibri" pitchFamily="34" charset="-122"/>
                 <a:cs typeface="Calibri" pitchFamily="34" charset="-120"/>
               </a:rPr>
-              <a:t>doi:10.1063/5.0300741；Fig. 1</a:t>
+              <a:t>doi:10.1063/5.0300741；Fig. 1 · Sources: doi:10.1063/5.0300741；Fig. 1</a:t>
             </a:r>
             <a:endParaRPr lang="en-US" sz="840" dirty="0"/>
           </a:p>
@@ -4392,7 +4392,7 @@
                 <a:ea typeface="Calibri" pitchFamily="34" charset="-122"/>
                 <a:cs typeface="Calibri" pitchFamily="34" charset="-120"/>
               </a:rPr>
-              <a:t>设计说明拆成版图、DRC、FDTD 等脚本子任务</a:t>
+              <a:t>48 个脚本任务：基础 12 / 中等 12 / 高级 24</a:t>
             </a:r>
             <a:endParaRPr lang="en-US" sz="1100" dirty="0"/>
           </a:p>
@@ -4456,7 +4456,7 @@
                 <a:ea typeface="Trebuchet MS" pitchFamily="34" charset="-122"/>
                 <a:cs typeface="Trebuchet MS" pitchFamily="34" charset="-120"/>
               </a:rPr>
-              <a:t>方法</a:t>
+              <a:t>内部反馈</a:t>
             </a:r>
             <a:endParaRPr lang="en-US" sz="1300" dirty="0"/>
           </a:p>
@@ -4500,7 +4500,7 @@
                 <a:ea typeface="Calibri" pitchFamily="34" charset="-122"/>
                 <a:cs typeface="Calibri" pitchFamily="34" charset="-120"/>
               </a:rPr>
-              <a:t>规划 + 工具手册检索 + 程序生成/合成 + 脚本评价</a:t>
+              <a:t>静态检查 + 自定义检查库 + LLM；并非求解器反馈</a:t>
             </a:r>
             <a:endParaRPr lang="en-US" sz="1100" dirty="0"/>
           </a:p>
@@ -4564,7 +4564,7 @@
                 <a:ea typeface="Trebuchet MS" pitchFamily="34" charset="-122"/>
                 <a:cs typeface="Trebuchet MS" pitchFamily="34" charset="-120"/>
               </a:rPr>
-              <a:t>证据边界</a:t>
+              <a:t>外部评分</a:t>
             </a:r>
             <a:endParaRPr lang="en-US" sz="1300" dirty="0"/>
           </a:p>
@@ -4608,7 +4608,7 @@
                 <a:ea typeface="Calibri" pitchFamily="34" charset="-122"/>
                 <a:cs typeface="Calibri" pitchFamily="34" charset="-120"/>
               </a:rPr>
-              <a:t>48 个脚本任务；作者报告全部完成，未核验公开实现和自治执行</a:t>
+              <a:t>脚本运行结果与参考输出相符；≥3/15 次才计 solved</a:t>
             </a:r>
             <a:endParaRPr lang="en-US" sz="1100" dirty="0"/>
           </a:p>
@@ -4713,7 +4713,7 @@
                 <a:ea typeface="Calibri" pitchFamily="34" charset="-122"/>
                 <a:cs typeface="Calibri" pitchFamily="34" charset="-120"/>
               </a:rPr>
-              <a:t>arXiv:2608.01791；Fig. 2</a:t>
+              <a:t>arXiv:2608.01791；Fig. 2 · Sources: arXiv:2608.01791；Fig. 2</a:t>
             </a:r>
             <a:endParaRPr lang="en-US" sz="840" dirty="0"/>
           </a:p>
@@ -5000,7 +5000,7 @@
                 <a:ea typeface="Trebuchet MS" pitchFamily="34" charset="-122"/>
                 <a:cs typeface="Trebuchet MS" pitchFamily="34" charset="-120"/>
               </a:rPr>
-              <a:t>任务</a:t>
+              <a:t>规则与反馈</a:t>
             </a:r>
             <a:endParaRPr lang="en-US" sz="1300" dirty="0"/>
           </a:p>
@@ -5044,7 +5044,7 @@
                 <a:ea typeface="Calibri" pitchFamily="34" charset="-122"/>
                 <a:cs typeface="Calibri" pitchFamily="34" charset="-120"/>
               </a:rPr>
-              <a:t>人类定义目标、约束和评价程序</a:t>
+              <a:t>人类定目标；显式 DRC → Tidy3D 等求解器 → 定量验收</a:t>
             </a:r>
             <a:endParaRPr lang="en-US" sz="1100" dirty="0"/>
           </a:p>
@@ -5108,7 +5108,7 @@
                 <a:ea typeface="Trebuchet MS" pitchFamily="34" charset="-122"/>
                 <a:cs typeface="Trebuchet MS" pitchFamily="34" charset="-120"/>
               </a:rPr>
-              <a:t>闭环</a:t>
+              <a:t>原图案例</a:t>
             </a:r>
             <a:endParaRPr lang="en-US" sz="1300" dirty="0"/>
           </a:p>
@@ -5152,7 +5152,7 @@
                 <a:ea typeface="Calibri" pitchFamily="34" charset="-122"/>
                 <a:cs typeface="Calibri" pitchFamily="34" charset="-120"/>
               </a:rPr>
-              <a:t>提出设计 → Tidy3D 求解 → 评价 → 保留/修正</a:t>
+              <a:t>12 µm SiN 弯曲：0.460 → 0.109 dB，50 次预算</a:t>
             </a:r>
             <a:endParaRPr lang="en-US" sz="1100" dirty="0"/>
           </a:p>
@@ -5260,7 +5260,7 @@
                 <a:ea typeface="Calibri" pitchFamily="34" charset="-122"/>
                 <a:cs typeface="Calibri" pitchFamily="34" charset="-120"/>
               </a:rPr>
-              <a:t>器件级仿真在环；专家设置和纠错仍重要</a:t>
+              <a:t>多物理 MZM 初始设置由专家纠错；结果是数值仿真</a:t>
             </a:r>
             <a:endParaRPr lang="en-US" sz="1100" dirty="0"/>
           </a:p>
@@ -5365,7 +5365,7 @@
                 <a:ea typeface="Calibri" pitchFamily="34" charset="-122"/>
                 <a:cs typeface="Calibri" pitchFamily="34" charset="-120"/>
               </a:rPr>
-              <a:t>arXiv:2606.00915；Fig. 2</a:t>
+              <a:t>arXiv:2606.00915；Fig. 2 · Sources: arXiv:2606.00915；Fig. 2</a:t>
             </a:r>
             <a:endParaRPr lang="en-US" sz="840" dirty="0"/>
           </a:p>
@@ -5500,7 +5500,7 @@
                 <a:ea typeface="Trebuchet MS" pitchFamily="34" charset="-122"/>
                 <a:cs typeface="Trebuchet MS" pitchFamily="34" charset="-120"/>
               </a:rPr>
-              <a:t>代表性工作覆盖了不同设计环节</a:t>
+              <a:t>PhIDO、PICopilot、Kharel：成功定义不同</a:t>
             </a:r>
             <a:endParaRPr lang="en-US" sz="2600" dirty="0"/>
           </a:p>
@@ -5539,7 +5539,7 @@
                 <a:ea typeface="Calibri" pitchFamily="34" charset="-122"/>
                 <a:cs typeface="Calibri" pitchFamily="34" charset="-120"/>
               </a:rPr>
-              <a:t>对比的是论文所展示的任务与证据层级</a:t>
+              <a:t>结构/GDS、脚本功能、数值验收分别位于不同层级</a:t>
             </a:r>
             <a:endParaRPr lang="en-US" sz="1300" dirty="0"/>
           </a:p>
@@ -5608,7 +5608,7 @@
                 <a:ea typeface="Calibri" pitchFamily="34" charset="-122"/>
                 <a:cs typeface="Calibri" pitchFamily="34" charset="-120"/>
               </a:rPr>
-              <a:t>依据：TASK-005 能力矩阵；TASK-007 §4.2；四篇原文</a:t>
+              <a:t>依据：PhIDO Fig. 1/Table II；PICopilot Fig. 2/Table 2–3；Kharel Fig. 1/Table S2</a:t>
             </a:r>
             <a:endParaRPr lang="en-US" sz="1100" dirty="0"/>
           </a:p>
@@ -6966,7 +6966,7 @@
                 <a:ea typeface="Calibri" pitchFamily="34" charset="-122"/>
                 <a:cs typeface="Calibri" pitchFamily="34" charset="-120"/>
               </a:rPr>
-              <a:t>来源：TASK-007 正式报告与候选路线；用户确认的最新研究倾向</a:t>
+              <a:t>来源：TASK-007 正式报告与候选路线；用户确认的最新研究倾向 · Sources: TASK-007 正式报告与候选路线；用户确认的最新研究倾向</a:t>
             </a:r>
             <a:endParaRPr lang="en-US" sz="840" dirty="0"/>
           </a:p>
@@ -7509,7 +7509,7 @@
                 <a:ea typeface="Trebuchet MS" pitchFamily="34" charset="-122"/>
                 <a:cs typeface="Trebuchet MS" pitchFamily="34" charset="-120"/>
               </a:rPr>
-              <a:t>DAS 集成：比较功能边界，而非只比芯片尺寸</a:t>
+              <a:t>Jin 2024：SOI 芯片进入真实 DAS 收发链路</a:t>
             </a:r>
             <a:endParaRPr lang="en-US" sz="2600" dirty="0"/>
           </a:p>
@@ -7548,7 +7548,7 @@
                 <a:ea typeface="Calibri" pitchFamily="34" charset="-122"/>
                 <a:cs typeface="Calibri" pitchFamily="34" charset="-120"/>
               </a:rPr>
-              <a:t>器件、PIC、混合模块与系统级演示是不同层级</a:t>
+              <a:t>片上 MZM、偏振处理、相干混合与探测；片外模块另列</a:t>
             </a:r>
             <a:endParaRPr lang="en-US" sz="1300" dirty="0"/>
           </a:p>
@@ -7617,7 +7617,7 @@
                 <a:ea typeface="Calibri" pitchFamily="34" charset="-122"/>
                 <a:cs typeface="Calibri" pitchFamily="34" charset="-120"/>
               </a:rPr>
-              <a:t>依据：Jin 等 2024, Photonics Research；Jin 等 2026, OFC W4D.2</a:t>
+              <a:t>根据 Jin 等（2024）Fig. 1(b)/3/5/6 改绘；doi:10.1364/PRJ.512298</a:t>
             </a:r>
             <a:endParaRPr lang="en-US" sz="1100" dirty="0"/>
           </a:p>
@@ -7713,7 +7713,7 @@
                 <a:ea typeface="Trebuchet MS" pitchFamily="34" charset="-122"/>
                 <a:cs typeface="Trebuchet MS" pitchFamily="34" charset="-120"/>
               </a:rPr>
-              <a:t>Jin 等：混合集成模块进入 10 km DAS 演示</a:t>
+              <a:t>Cheng 2023：四微环结构针对 DAS 发射脉冲</a:t>
             </a:r>
             <a:endParaRPr lang="en-US" sz="2600" dirty="0"/>
           </a:p>
@@ -7752,36 +7752,55 @@
                 <a:ea typeface="Calibri" pitchFamily="34" charset="-122"/>
                 <a:cs typeface="Calibri" pitchFamily="34" charset="-120"/>
               </a:rPr>
-              <a:t>InP 激光 + 微光学 + SOI 收发 PIC + TEC</a:t>
+              <a:t>原论文 Fig. 1 显示耦合微环、透射谱与脉冲响应</a:t>
             </a:r>
             <a:endParaRPr lang="en-US" sz="1300" dirty="0"/>
           </a:p>
         </p:txBody>
+      </p:sp>
+      <p:sp>
+        <p:nvSpPr>
+          <p:cNvPr id="5" name="Shape 3"/>
+          <p:cNvSpPr/>
+          <p:nvPr/>
+        </p:nvSpPr>
+        <p:spPr>
+          <a:xfrm>
+            <a:off x="457200" y="1235964"/>
+            <a:ext cx="4608576" cy="3112008"/>
+          </a:xfrm>
+          <a:prstGeom prst="rect">
+            <a:avLst/>
+          </a:prstGeom>
+          <a:solidFill>
+            <a:srgbClr val="FFFFFF"/>
+          </a:solidFill>
+          <a:ln w="9525">
+            <a:solidFill>
+              <a:srgbClr val="E5E7EB"/>
+            </a:solidFill>
+            <a:prstDash val="solid"/>
+          </a:ln>
+        </p:spPr>
       </p:sp>
       <p:pic>
         <p:nvPicPr>
-          <p:cNvPr id="5" name="Image 0" descr="G:\PIC_Harness_Research\presentations\task-010-group-meeting-rebuild\assets\p06-jin-module.svg">    </p:cNvPr>
+          <p:cNvPr id="6" name="Image 0" descr="G:\PIC_Harness_Research\presentations\task-010-group-meeting-rebuild\assets\cheng-fig1-device-spectrum.png">    </p:cNvPr>
           <p:cNvPicPr>
             <a:picLocks noChangeAspect="1"/>
           </p:cNvPicPr>
           <p:nvPr/>
         </p:nvPicPr>
         <p:blipFill>
-          <a:blip r:embed="rId1">
-            <a:extLst>
-              <a:ext uri="{96DAC541-7B7A-43D3-8B79-37D633B846F1}">
-                <asvg:svgBlip xmlns:asvg="http://schemas.microsoft.com/office/drawing/2016/SVG/main" r:embed="rId2"/>
-              </a:ext>
-            </a:extLst>
-          </a:blip>
+          <a:blip r:embed="rId1"/>
           <a:stretch>
             <a:fillRect/>
           </a:stretch>
         </p:blipFill>
         <p:spPr>
           <a:xfrm>
-            <a:off x="457200" y="1208532"/>
-            <a:ext cx="8229600" cy="3569208"/>
+            <a:off x="512064" y="1484870"/>
+            <a:ext cx="4498848" cy="2614195"/>
           </a:xfrm>
           <a:prstGeom prst="rect">
             <a:avLst/>
@@ -7790,40 +7809,469 @@
       </p:pic>
       <p:sp>
         <p:nvSpPr>
-          <p:cNvPr id="6" name="Text 3"/>
-          <p:cNvSpPr txBox="1"/>
-          <p:nvPr/>
-        </p:nvSpPr>
-        <p:spPr>
-          <a:xfrm>
-            <a:off x="457200" y="4777740"/>
-            <a:ext cx="8229600" cy="274320"/>
-          </a:xfrm>
-          <a:prstGeom prst="rect">
-            <a:avLst/>
-          </a:prstGeom>
-          <a:noFill/>
-          <a:ln/>
-        </p:spPr>
-        <p:txBody>
-          <a:bodyPr wrap="square" lIns="0" tIns="0" rIns="0" bIns="0" rtlCol="0" anchor="ctr"/>
-          <a:lstStyle/>
-          <a:p>
-            <a:pPr algn="l" indent="0" marL="0">
+          <p:cNvPr id="7" name="Shape 4"/>
+          <p:cNvSpPr/>
+          <p:nvPr/>
+        </p:nvSpPr>
+        <p:spPr>
+          <a:xfrm>
+            <a:off x="5340096" y="1235964"/>
+            <a:ext cx="36576" cy="976376"/>
+          </a:xfrm>
+          <a:prstGeom prst="rect">
+            <a:avLst/>
+          </a:prstGeom>
+          <a:solidFill>
+            <a:srgbClr val="D4461E"/>
+          </a:solidFill>
+          <a:ln w="12700">
+            <a:solidFill>
+              <a:srgbClr val="D4461E"/>
+            </a:solidFill>
+            <a:prstDash val="solid"/>
+          </a:ln>
+        </p:spPr>
+      </p:sp>
+      <p:sp>
+        <p:nvSpPr>
+          <p:cNvPr id="8" name="Text 5"/>
+          <p:cNvSpPr txBox="1"/>
+          <p:nvPr/>
+        </p:nvSpPr>
+        <p:spPr>
+          <a:xfrm>
+            <a:off x="5468112" y="1235964"/>
+            <a:ext cx="3218688" cy="219456"/>
+          </a:xfrm>
+          <a:prstGeom prst="rect">
+            <a:avLst/>
+          </a:prstGeom>
+          <a:noFill/>
+          <a:ln/>
+        </p:spPr>
+        <p:txBody>
+          <a:bodyPr wrap="square" lIns="0" tIns="0" rIns="0" bIns="0" rtlCol="0" anchor="t"/>
+          <a:lstStyle/>
+          <a:p>
+            <a:pPr algn="l" indent="0" marL="0">
+              <a:buNone/>
+            </a:pPr>
+            <a:r>
+              <a:rPr lang="en-US" sz="1300" b="1" dirty="0">
+                <a:solidFill>
+                  <a:srgbClr val="D4461E"/>
+                </a:solidFill>
+                <a:latin typeface="Trebuchet MS" pitchFamily="34" charset="0"/>
+                <a:ea typeface="Trebuchet MS" pitchFamily="34" charset="-122"/>
+                <a:cs typeface="Trebuchet MS" pitchFamily="34" charset="-120"/>
+              </a:rPr>
+              <a:t>结构</a:t>
+            </a:r>
+            <a:endParaRPr lang="en-US" sz="1300" dirty="0"/>
+          </a:p>
+        </p:txBody>
+      </p:sp>
+      <p:sp>
+        <p:nvSpPr>
+          <p:cNvPr id="9" name="Text 6"/>
+          <p:cNvSpPr txBox="1"/>
+          <p:nvPr/>
+        </p:nvSpPr>
+        <p:spPr>
+          <a:xfrm>
+            <a:off x="5468112" y="1510284"/>
+            <a:ext cx="3218688" cy="329184"/>
+          </a:xfrm>
+          <a:prstGeom prst="rect">
+            <a:avLst/>
+          </a:prstGeom>
+          <a:noFill/>
+          <a:ln/>
+        </p:spPr>
+        <p:txBody>
+          <a:bodyPr wrap="square" lIns="0" tIns="0" rIns="0" bIns="0" rtlCol="0" anchor="t">
+            <a:normAutofit/>
+          </a:bodyPr>
+          <a:lstStyle/>
+          <a:p>
+            <a:pPr algn="l" indent="0" marL="0">
+              <a:spcAft>
+                <a:spcPts val="300"/>
+              </a:spcAft>
               <a:buNone/>
             </a:pPr>
             <a:r>
               <a:rPr lang="en-US" sz="1100" dirty="0">
                 <a:solidFill>
-                  <a:srgbClr val="6B7280"/>
+                  <a:srgbClr val="0A0A0A"/>
                 </a:solidFill>
                 <a:latin typeface="Calibri" pitchFamily="34" charset="0"/>
                 <a:ea typeface="Calibri" pitchFamily="34" charset="-122"/>
                 <a:cs typeface="Calibri" pitchFamily="34" charset="-120"/>
               </a:rPr>
-              <a:t>根据 Jin 等（2026）OFC W4D.2 改绘；doi:10.1364/OFC.2026.W4D.2</a:t>
+              <a:t>4 个 10 µm 微环 + PIN 注入；通带与带外抑制</a:t>
             </a:r>
             <a:endParaRPr lang="en-US" sz="1100" dirty="0"/>
+          </a:p>
+        </p:txBody>
+      </p:sp>
+      <p:sp>
+        <p:nvSpPr>
+          <p:cNvPr id="10" name="Shape 7"/>
+          <p:cNvSpPr/>
+          <p:nvPr/>
+        </p:nvSpPr>
+        <p:spPr>
+          <a:xfrm>
+            <a:off x="5340096" y="2303780"/>
+            <a:ext cx="36576" cy="976376"/>
+          </a:xfrm>
+          <a:prstGeom prst="rect">
+            <a:avLst/>
+          </a:prstGeom>
+          <a:solidFill>
+            <a:srgbClr val="1F2937"/>
+          </a:solidFill>
+          <a:ln w="12700">
+            <a:solidFill>
+              <a:srgbClr val="1F2937"/>
+            </a:solidFill>
+            <a:prstDash val="solid"/>
+          </a:ln>
+        </p:spPr>
+      </p:sp>
+      <p:sp>
+        <p:nvSpPr>
+          <p:cNvPr id="11" name="Text 8"/>
+          <p:cNvSpPr txBox="1"/>
+          <p:nvPr/>
+        </p:nvSpPr>
+        <p:spPr>
+          <a:xfrm>
+            <a:off x="5468112" y="2303780"/>
+            <a:ext cx="3218688" cy="219456"/>
+          </a:xfrm>
+          <a:prstGeom prst="rect">
+            <a:avLst/>
+          </a:prstGeom>
+          <a:noFill/>
+          <a:ln/>
+        </p:spPr>
+        <p:txBody>
+          <a:bodyPr wrap="square" lIns="0" tIns="0" rIns="0" bIns="0" rtlCol="0" anchor="t"/>
+          <a:lstStyle/>
+          <a:p>
+            <a:pPr algn="l" indent="0" marL="0">
+              <a:buNone/>
+            </a:pPr>
+            <a:r>
+              <a:rPr lang="en-US" sz="1300" b="1" dirty="0">
+                <a:solidFill>
+                  <a:srgbClr val="1F2937"/>
+                </a:solidFill>
+                <a:latin typeface="Trebuchet MS" pitchFamily="34" charset="0"/>
+                <a:ea typeface="Trebuchet MS" pitchFamily="34" charset="-122"/>
+                <a:cs typeface="Trebuchet MS" pitchFamily="34" charset="-120"/>
+              </a:rPr>
+              <a:t>器件</a:t>
+            </a:r>
+            <a:endParaRPr lang="en-US" sz="1300" dirty="0"/>
+          </a:p>
+        </p:txBody>
+      </p:sp>
+      <p:sp>
+        <p:nvSpPr>
+          <p:cNvPr id="12" name="Text 9"/>
+          <p:cNvSpPr txBox="1"/>
+          <p:nvPr/>
+        </p:nvSpPr>
+        <p:spPr>
+          <a:xfrm>
+            <a:off x="5468112" y="2578100"/>
+            <a:ext cx="3218688" cy="329184"/>
+          </a:xfrm>
+          <a:prstGeom prst="rect">
+            <a:avLst/>
+          </a:prstGeom>
+          <a:noFill/>
+          <a:ln/>
+        </p:spPr>
+        <p:txBody>
+          <a:bodyPr wrap="square" lIns="0" tIns="0" rIns="0" bIns="0" rtlCol="0" anchor="t">
+            <a:normAutofit/>
+          </a:bodyPr>
+          <a:lstStyle/>
+          <a:p>
+            <a:pPr algn="l" indent="0" marL="0">
+              <a:spcAft>
+                <a:spcPts val="300"/>
+              </a:spcAft>
+              <a:buNone/>
+            </a:pPr>
+            <a:r>
+              <a:rPr lang="en-US" sz="1100" dirty="0">
+                <a:solidFill>
+                  <a:srgbClr val="0A0A0A"/>
+                </a:solidFill>
+                <a:latin typeface="Calibri" pitchFamily="34" charset="0"/>
+                <a:ea typeface="Calibri" pitchFamily="34" charset="-122"/>
+                <a:cs typeface="Calibri" pitchFamily="34" charset="-120"/>
+              </a:rPr>
+              <a:t>动态 ER 68 dB；3.60 mW；上升/下降 6.54/0.40 ns</a:t>
+            </a:r>
+            <a:endParaRPr lang="en-US" sz="1100" dirty="0"/>
+          </a:p>
+        </p:txBody>
+      </p:sp>
+      <p:sp>
+        <p:nvSpPr>
+          <p:cNvPr id="13" name="Shape 10"/>
+          <p:cNvSpPr/>
+          <p:nvPr/>
+        </p:nvSpPr>
+        <p:spPr>
+          <a:xfrm>
+            <a:off x="5340096" y="3371596"/>
+            <a:ext cx="36576" cy="976376"/>
+          </a:xfrm>
+          <a:prstGeom prst="rect">
+            <a:avLst/>
+          </a:prstGeom>
+          <a:solidFill>
+            <a:srgbClr val="D4461E"/>
+          </a:solidFill>
+          <a:ln w="12700">
+            <a:solidFill>
+              <a:srgbClr val="D4461E"/>
+            </a:solidFill>
+            <a:prstDash val="solid"/>
+          </a:ln>
+        </p:spPr>
+      </p:sp>
+      <p:sp>
+        <p:nvSpPr>
+          <p:cNvPr id="14" name="Text 11"/>
+          <p:cNvSpPr txBox="1"/>
+          <p:nvPr/>
+        </p:nvSpPr>
+        <p:spPr>
+          <a:xfrm>
+            <a:off x="5468112" y="3371596"/>
+            <a:ext cx="3218688" cy="219456"/>
+          </a:xfrm>
+          <a:prstGeom prst="rect">
+            <a:avLst/>
+          </a:prstGeom>
+          <a:noFill/>
+          <a:ln/>
+        </p:spPr>
+        <p:txBody>
+          <a:bodyPr wrap="square" lIns="0" tIns="0" rIns="0" bIns="0" rtlCol="0" anchor="t"/>
+          <a:lstStyle/>
+          <a:p>
+            <a:pPr algn="l" indent="0" marL="0">
+              <a:buNone/>
+            </a:pPr>
+            <a:r>
+              <a:rPr lang="en-US" sz="1300" b="1" dirty="0">
+                <a:solidFill>
+                  <a:srgbClr val="D4461E"/>
+                </a:solidFill>
+                <a:latin typeface="Trebuchet MS" pitchFamily="34" charset="0"/>
+                <a:ea typeface="Trebuchet MS" pitchFamily="34" charset="-122"/>
+                <a:cs typeface="Trebuchet MS" pitchFamily="34" charset="-120"/>
+              </a:rPr>
+              <a:t>系统边界</a:t>
+            </a:r>
+            <a:endParaRPr lang="en-US" sz="1300" dirty="0"/>
+          </a:p>
+        </p:txBody>
+      </p:sp>
+      <p:sp>
+        <p:nvSpPr>
+          <p:cNvPr id="15" name="Text 12"/>
+          <p:cNvSpPr txBox="1"/>
+          <p:nvPr/>
+        </p:nvSpPr>
+        <p:spPr>
+          <a:xfrm>
+            <a:off x="5468112" y="3645916"/>
+            <a:ext cx="3218688" cy="329184"/>
+          </a:xfrm>
+          <a:prstGeom prst="rect">
+            <a:avLst/>
+          </a:prstGeom>
+          <a:noFill/>
+          <a:ln/>
+        </p:spPr>
+        <p:txBody>
+          <a:bodyPr wrap="square" lIns="0" tIns="0" rIns="0" bIns="0" rtlCol="0" anchor="t">
+            <a:normAutofit/>
+          </a:bodyPr>
+          <a:lstStyle/>
+          <a:p>
+            <a:pPr algn="l" indent="0" marL="0">
+              <a:spcAft>
+                <a:spcPts val="300"/>
+              </a:spcAft>
+              <a:buNone/>
+            </a:pPr>
+            <a:r>
+              <a:rPr lang="en-US" sz="1100" dirty="0">
+                <a:solidFill>
+                  <a:srgbClr val="0A0A0A"/>
+                </a:solidFill>
+                <a:latin typeface="Calibri" pitchFamily="34" charset="0"/>
+                <a:ea typeface="Calibri" pitchFamily="34" charset="-122"/>
+                <a:cs typeface="Calibri" pitchFamily="34" charset="-120"/>
+              </a:rPr>
+              <a:t>2 km DAS 为 EOM 子模块替换；激光/EDFA/接收仍片外</a:t>
+            </a:r>
+            <a:endParaRPr lang="en-US" sz="1100" dirty="0"/>
+          </a:p>
+        </p:txBody>
+      </p:sp>
+      <p:sp>
+        <p:nvSpPr>
+          <p:cNvPr id="16" name="Text 13"/>
+          <p:cNvSpPr txBox="1"/>
+          <p:nvPr/>
+        </p:nvSpPr>
+        <p:spPr>
+          <a:xfrm>
+            <a:off x="457200" y="4375404"/>
+            <a:ext cx="8229600" cy="201168"/>
+          </a:xfrm>
+          <a:prstGeom prst="rect">
+            <a:avLst/>
+          </a:prstGeom>
+          <a:noFill/>
+          <a:ln/>
+        </p:spPr>
+        <p:txBody>
+          <a:bodyPr wrap="square" lIns="0" tIns="0" rIns="0" bIns="0" rtlCol="0" anchor="t"/>
+          <a:lstStyle/>
+          <a:p>
+            <a:pPr algn="l" indent="0" marL="0">
+              <a:buNone/>
+            </a:pPr>
+            <a:r>
+              <a:rPr lang="en-US" sz="1050" i="1" dirty="0">
+                <a:solidFill>
+                  <a:srgbClr val="6B7280"/>
+                </a:solidFill>
+                <a:latin typeface="Calibri" pitchFamily="34" charset="0"/>
+                <a:ea typeface="Calibri" pitchFamily="34" charset="-122"/>
+                <a:cs typeface="Calibri" pitchFamily="34" charset="-120"/>
+              </a:rPr>
+              <a:t>Cheng 等（2023），Nature Communications，Fig. 1(a–f) 原图；CC BY 4.0。</a:t>
+            </a:r>
+            <a:endParaRPr lang="en-US" sz="1050" dirty="0"/>
+          </a:p>
+        </p:txBody>
+      </p:sp>
+      <p:sp>
+        <p:nvSpPr>
+          <p:cNvPr id="17" name="Shape 14"/>
+          <p:cNvSpPr/>
+          <p:nvPr/>
+        </p:nvSpPr>
+        <p:spPr>
+          <a:xfrm>
+            <a:off x="457200" y="4814316"/>
+            <a:ext cx="8229600" cy="18288"/>
+          </a:xfrm>
+          <a:prstGeom prst="rect">
+            <a:avLst/>
+          </a:prstGeom>
+          <a:solidFill>
+            <a:srgbClr val="E5E7EB"/>
+          </a:solidFill>
+          <a:ln w="12700">
+            <a:solidFill>
+              <a:srgbClr val="FFFFFF"/>
+            </a:solidFill>
+            <a:prstDash val="solid"/>
+          </a:ln>
+        </p:spPr>
+      </p:sp>
+      <p:sp>
+        <p:nvSpPr>
+          <p:cNvPr id="18" name="Text 15"/>
+          <p:cNvSpPr txBox="1"/>
+          <p:nvPr/>
+        </p:nvSpPr>
+        <p:spPr>
+          <a:xfrm>
+            <a:off x="457200" y="4869180"/>
+            <a:ext cx="7580376" cy="274320"/>
+          </a:xfrm>
+          <a:prstGeom prst="rect">
+            <a:avLst/>
+          </a:prstGeom>
+          <a:noFill/>
+          <a:ln/>
+        </p:spPr>
+        <p:txBody>
+          <a:bodyPr wrap="square" lIns="0" tIns="0" rIns="0" bIns="0" rtlCol="0" anchor="ctr">
+            <a:normAutofit/>
+          </a:bodyPr>
+          <a:lstStyle/>
+          <a:p>
+            <a:pPr algn="l" indent="0" marL="0">
+              <a:buNone/>
+            </a:pPr>
+            <a:r>
+              <a:rPr lang="en-US" sz="840" dirty="0">
+                <a:solidFill>
+                  <a:srgbClr val="6B7280"/>
+                </a:solidFill>
+                <a:latin typeface="Calibri" pitchFamily="34" charset="0"/>
+                <a:ea typeface="Calibri" pitchFamily="34" charset="-122"/>
+                <a:cs typeface="Calibri" pitchFamily="34" charset="-120"/>
+              </a:rPr>
+              <a:t>doi:10.1038/s41467-023-43244-9；Fig. 1/2/4/5 · Sources: doi:10.1038/s41467-023-43244-9；Fig. 1/2/4/5</a:t>
+            </a:r>
+            <a:endParaRPr lang="en-US" sz="840" dirty="0"/>
+          </a:p>
+        </p:txBody>
+      </p:sp>
+      <p:sp>
+        <p:nvSpPr>
+          <p:cNvPr id="19" name="Text 16"/>
+          <p:cNvSpPr txBox="1"/>
+          <p:nvPr/>
+        </p:nvSpPr>
+        <p:spPr>
+          <a:xfrm>
+            <a:off x="8183880" y="4869180"/>
+            <a:ext cx="502920" cy="274320"/>
+          </a:xfrm>
+          <a:prstGeom prst="rect">
+            <a:avLst/>
+          </a:prstGeom>
+          <a:noFill/>
+          <a:ln/>
+        </p:spPr>
+        <p:txBody>
+          <a:bodyPr wrap="square" lIns="0" tIns="0" rIns="0" bIns="0" rtlCol="0" anchor="ctr"/>
+          <a:lstStyle/>
+          <a:p>
+            <a:pPr algn="r" indent="0" marL="0">
+              <a:buNone/>
+            </a:pPr>
+            <a:r>
+              <a:rPr lang="en-US" sz="840" dirty="0">
+                <a:solidFill>
+                  <a:srgbClr val="6B7280"/>
+                </a:solidFill>
+                <a:latin typeface="Calibri" pitchFamily="34" charset="0"/>
+                <a:ea typeface="Calibri" pitchFamily="34" charset="-122"/>
+                <a:cs typeface="Calibri" pitchFamily="34" charset="-120"/>
+              </a:rPr>
+              <a:t>6/20</a:t>
+            </a:r>
+            <a:endParaRPr lang="en-US" sz="840" dirty="0"/>
           </a:p>
         </p:txBody>
       </p:sp>
@@ -8325,7 +8773,7 @@
                 <a:ea typeface="Trebuchet MS" pitchFamily="34" charset="-122"/>
                 <a:cs typeface="Trebuchet MS" pitchFamily="34" charset="-120"/>
               </a:rPr>
-              <a:t>ACCEL：任务级视觉演示与计算边界</a:t>
+              <a:t>Ahmed 2025：光子核心与电子系统共同运行 AI</a:t>
             </a:r>
             <a:endParaRPr lang="en-US" sz="2600" dirty="0"/>
           </a:p>
@@ -8364,55 +8812,36 @@
                 <a:ea typeface="Calibri" pitchFamily="34" charset="-122"/>
                 <a:cs typeface="Calibri" pitchFamily="34" charset="-120"/>
               </a:rPr>
-              <a:t>原论文 Fig. 1(b) 展示衍射光学编码与模拟电子计算</a:t>
+              <a:t>根据原论文 Fig. 2 改绘；任务准确率见 Table 1</a:t>
             </a:r>
             <a:endParaRPr lang="en-US" sz="1300" dirty="0"/>
           </a:p>
         </p:txBody>
-      </p:sp>
-      <p:sp>
-        <p:nvSpPr>
-          <p:cNvPr id="5" name="Shape 3"/>
-          <p:cNvSpPr/>
-          <p:nvPr/>
-        </p:nvSpPr>
-        <p:spPr>
-          <a:xfrm>
-            <a:off x="457200" y="1235964"/>
-            <a:ext cx="4608576" cy="3112008"/>
-          </a:xfrm>
-          <a:prstGeom prst="rect">
-            <a:avLst/>
-          </a:prstGeom>
-          <a:solidFill>
-            <a:srgbClr val="FFFFFF"/>
-          </a:solidFill>
-          <a:ln w="9525">
-            <a:solidFill>
-              <a:srgbClr val="E5E7EB"/>
-            </a:solidFill>
-            <a:prstDash val="solid"/>
-          </a:ln>
-        </p:spPr>
       </p:sp>
       <p:pic>
         <p:nvPicPr>
-          <p:cNvPr id="6" name="Image 0" descr="G:\PIC_Harness_Research\presentations\task-010-group-meeting-rebuild\assets\accel-fig1b.png">    </p:cNvPr>
+          <p:cNvPr id="5" name="Image 0" descr="G:\PIC_Harness_Research\presentations\task-010-group-meeting-rebuild\assets\p09-ahmed-system.svg">    </p:cNvPr>
           <p:cNvPicPr>
             <a:picLocks noChangeAspect="1"/>
           </p:cNvPicPr>
           <p:nvPr/>
         </p:nvPicPr>
         <p:blipFill>
-          <a:blip r:embed="rId1"/>
+          <a:blip r:embed="rId1">
+            <a:extLst>
+              <a:ext uri="{96DAC541-7B7A-43D3-8B79-37D633B846F1}">
+                <asvg:svgBlip xmlns:asvg="http://schemas.microsoft.com/office/drawing/2016/SVG/main" r:embed="rId2"/>
+              </a:ext>
+            </a:extLst>
+          </a:blip>
           <a:stretch>
             <a:fillRect/>
           </a:stretch>
         </p:blipFill>
         <p:spPr>
           <a:xfrm>
-            <a:off x="512064" y="2167669"/>
-            <a:ext cx="4498848" cy="1248598"/>
+            <a:off x="457200" y="1208532"/>
+            <a:ext cx="8229600" cy="3569208"/>
           </a:xfrm>
           <a:prstGeom prst="rect">
             <a:avLst/>
@@ -8421,469 +8850,40 @@
       </p:pic>
       <p:sp>
         <p:nvSpPr>
-          <p:cNvPr id="7" name="Shape 4"/>
-          <p:cNvSpPr/>
-          <p:nvPr/>
-        </p:nvSpPr>
-        <p:spPr>
-          <a:xfrm>
-            <a:off x="5340096" y="1235964"/>
-            <a:ext cx="36576" cy="976376"/>
-          </a:xfrm>
-          <a:prstGeom prst="rect">
-            <a:avLst/>
-          </a:prstGeom>
-          <a:solidFill>
-            <a:srgbClr val="D4461E"/>
-          </a:solidFill>
-          <a:ln w="12700">
-            <a:solidFill>
-              <a:srgbClr val="D4461E"/>
-            </a:solidFill>
-            <a:prstDash val="solid"/>
-          </a:ln>
-        </p:spPr>
-      </p:sp>
-      <p:sp>
-        <p:nvSpPr>
-          <p:cNvPr id="8" name="Text 5"/>
-          <p:cNvSpPr txBox="1"/>
-          <p:nvPr/>
-        </p:nvSpPr>
-        <p:spPr>
-          <a:xfrm>
-            <a:off x="5468112" y="1235964"/>
-            <a:ext cx="3218688" cy="219456"/>
-          </a:xfrm>
-          <a:prstGeom prst="rect">
-            <a:avLst/>
-          </a:prstGeom>
-          <a:noFill/>
-          <a:ln/>
-        </p:spPr>
-        <p:txBody>
-          <a:bodyPr wrap="square" lIns="0" tIns="0" rIns="0" bIns="0" rtlCol="0" anchor="t"/>
-          <a:lstStyle/>
-          <a:p>
-            <a:pPr algn="l" indent="0" marL="0">
-              <a:buNone/>
-            </a:pPr>
-            <a:r>
-              <a:rPr lang="en-US" sz="1300" b="1" dirty="0">
-                <a:solidFill>
-                  <a:srgbClr val="D4461E"/>
-                </a:solidFill>
-                <a:latin typeface="Trebuchet MS" pitchFamily="34" charset="0"/>
-                <a:ea typeface="Trebuchet MS" pitchFamily="34" charset="-122"/>
-                <a:cs typeface="Trebuchet MS" pitchFamily="34" charset="-120"/>
-              </a:rPr>
-              <a:t>结构</a:t>
-            </a:r>
-            <a:endParaRPr lang="en-US" sz="1300" dirty="0"/>
-          </a:p>
-        </p:txBody>
-      </p:sp>
-      <p:sp>
-        <p:nvSpPr>
-          <p:cNvPr id="9" name="Text 6"/>
-          <p:cNvSpPr txBox="1"/>
-          <p:nvPr/>
-        </p:nvSpPr>
-        <p:spPr>
-          <a:xfrm>
-            <a:off x="5468112" y="1510284"/>
-            <a:ext cx="3218688" cy="329184"/>
-          </a:xfrm>
-          <a:prstGeom prst="rect">
-            <a:avLst/>
-          </a:prstGeom>
-          <a:noFill/>
-          <a:ln/>
-        </p:spPr>
-        <p:txBody>
-          <a:bodyPr wrap="square" lIns="0" tIns="0" rIns="0" bIns="0" rtlCol="0" anchor="t">
-            <a:normAutofit/>
-          </a:bodyPr>
-          <a:lstStyle/>
-          <a:p>
-            <a:pPr algn="l" indent="0" marL="0">
-              <a:spcAft>
-                <a:spcPts val="300"/>
-              </a:spcAft>
+          <p:cNvPr id="6" name="Text 3"/>
+          <p:cNvSpPr txBox="1"/>
+          <p:nvPr/>
+        </p:nvSpPr>
+        <p:spPr>
+          <a:xfrm>
+            <a:off x="457200" y="4777740"/>
+            <a:ext cx="8229600" cy="274320"/>
+          </a:xfrm>
+          <a:prstGeom prst="rect">
+            <a:avLst/>
+          </a:prstGeom>
+          <a:noFill/>
+          <a:ln/>
+        </p:spPr>
+        <p:txBody>
+          <a:bodyPr wrap="square" lIns="0" tIns="0" rIns="0" bIns="0" rtlCol="0" anchor="ctr"/>
+          <a:lstStyle/>
+          <a:p>
+            <a:pPr algn="l" indent="0" marL="0">
               <a:buNone/>
             </a:pPr>
             <a:r>
               <a:rPr lang="en-US" sz="1100" dirty="0">
                 <a:solidFill>
-                  <a:srgbClr val="0A0A0A"/>
+                  <a:srgbClr val="6B7280"/>
                 </a:solidFill>
                 <a:latin typeface="Calibri" pitchFamily="34" charset="0"/>
                 <a:ea typeface="Calibri" pitchFamily="34" charset="-122"/>
                 <a:cs typeface="Calibri" pitchFamily="34" charset="-120"/>
               </a:rPr>
-              <a:t>衍射光学编码 OAC → 光电探测 → 模拟电子计算 EAC</a:t>
+              <a:t>根据 Ahmed 等（2025）Fig. 1/2、Table 1 改绘；doi:10.1038/s41586-025-08854-x</a:t>
             </a:r>
             <a:endParaRPr lang="en-US" sz="1100" dirty="0"/>
-          </a:p>
-        </p:txBody>
-      </p:sp>
-      <p:sp>
-        <p:nvSpPr>
-          <p:cNvPr id="10" name="Shape 7"/>
-          <p:cNvSpPr/>
-          <p:nvPr/>
-        </p:nvSpPr>
-        <p:spPr>
-          <a:xfrm>
-            <a:off x="5340096" y="2303780"/>
-            <a:ext cx="36576" cy="976376"/>
-          </a:xfrm>
-          <a:prstGeom prst="rect">
-            <a:avLst/>
-          </a:prstGeom>
-          <a:solidFill>
-            <a:srgbClr val="1F2937"/>
-          </a:solidFill>
-          <a:ln w="12700">
-            <a:solidFill>
-              <a:srgbClr val="1F2937"/>
-            </a:solidFill>
-            <a:prstDash val="solid"/>
-          </a:ln>
-        </p:spPr>
-      </p:sp>
-      <p:sp>
-        <p:nvSpPr>
-          <p:cNvPr id="11" name="Text 8"/>
-          <p:cNvSpPr txBox="1"/>
-          <p:nvPr/>
-        </p:nvSpPr>
-        <p:spPr>
-          <a:xfrm>
-            <a:off x="5468112" y="2303780"/>
-            <a:ext cx="3218688" cy="219456"/>
-          </a:xfrm>
-          <a:prstGeom prst="rect">
-            <a:avLst/>
-          </a:prstGeom>
-          <a:noFill/>
-          <a:ln/>
-        </p:spPr>
-        <p:txBody>
-          <a:bodyPr wrap="square" lIns="0" tIns="0" rIns="0" bIns="0" rtlCol="0" anchor="t"/>
-          <a:lstStyle/>
-          <a:p>
-            <a:pPr algn="l" indent="0" marL="0">
-              <a:buNone/>
-            </a:pPr>
-            <a:r>
-              <a:rPr lang="en-US" sz="1300" b="1" dirty="0">
-                <a:solidFill>
-                  <a:srgbClr val="1F2937"/>
-                </a:solidFill>
-                <a:latin typeface="Trebuchet MS" pitchFamily="34" charset="0"/>
-                <a:ea typeface="Trebuchet MS" pitchFamily="34" charset="-122"/>
-                <a:cs typeface="Trebuchet MS" pitchFamily="34" charset="-120"/>
-              </a:rPr>
-              <a:t>实验</a:t>
-            </a:r>
-            <a:endParaRPr lang="en-US" sz="1300" dirty="0"/>
-          </a:p>
-        </p:txBody>
-      </p:sp>
-      <p:sp>
-        <p:nvSpPr>
-          <p:cNvPr id="12" name="Text 9"/>
-          <p:cNvSpPr txBox="1"/>
-          <p:nvPr/>
-        </p:nvSpPr>
-        <p:spPr>
-          <a:xfrm>
-            <a:off x="5468112" y="2578100"/>
-            <a:ext cx="3218688" cy="468884"/>
-          </a:xfrm>
-          <a:prstGeom prst="rect">
-            <a:avLst/>
-          </a:prstGeom>
-          <a:noFill/>
-          <a:ln/>
-        </p:spPr>
-        <p:txBody>
-          <a:bodyPr wrap="square" lIns="0" tIns="0" rIns="0" bIns="0" rtlCol="0" anchor="t">
-            <a:normAutofit/>
-          </a:bodyPr>
-          <a:lstStyle/>
-          <a:p>
-            <a:pPr algn="l" indent="0" marL="0">
-              <a:spcAft>
-                <a:spcPts val="300"/>
-              </a:spcAft>
-              <a:buNone/>
-            </a:pPr>
-            <a:r>
-              <a:rPr lang="en-US" sz="1100" dirty="0">
-                <a:solidFill>
-                  <a:srgbClr val="0A0A0A"/>
-                </a:solidFill>
-                <a:latin typeface="Calibri" pitchFamily="34" charset="0"/>
-                <a:ea typeface="Calibri" pitchFamily="34" charset="-122"/>
-                <a:cs typeface="Calibri" pitchFamily="34" charset="-120"/>
-              </a:rPr>
-              <a:t>作者报告准确率：Fashion-MNIST 85.5%；三类 ImageNet 82.0%；视频 92.6%</a:t>
-            </a:r>
-            <a:endParaRPr lang="en-US" sz="1100" dirty="0"/>
-          </a:p>
-        </p:txBody>
-      </p:sp>
-      <p:sp>
-        <p:nvSpPr>
-          <p:cNvPr id="13" name="Shape 10"/>
-          <p:cNvSpPr/>
-          <p:nvPr/>
-        </p:nvSpPr>
-        <p:spPr>
-          <a:xfrm>
-            <a:off x="5340096" y="3371596"/>
-            <a:ext cx="36576" cy="976376"/>
-          </a:xfrm>
-          <a:prstGeom prst="rect">
-            <a:avLst/>
-          </a:prstGeom>
-          <a:solidFill>
-            <a:srgbClr val="D4461E"/>
-          </a:solidFill>
-          <a:ln w="12700">
-            <a:solidFill>
-              <a:srgbClr val="D4461E"/>
-            </a:solidFill>
-            <a:prstDash val="solid"/>
-          </a:ln>
-        </p:spPr>
-      </p:sp>
-      <p:sp>
-        <p:nvSpPr>
-          <p:cNvPr id="14" name="Text 11"/>
-          <p:cNvSpPr txBox="1"/>
-          <p:nvPr/>
-        </p:nvSpPr>
-        <p:spPr>
-          <a:xfrm>
-            <a:off x="5468112" y="3371596"/>
-            <a:ext cx="3218688" cy="219456"/>
-          </a:xfrm>
-          <a:prstGeom prst="rect">
-            <a:avLst/>
-          </a:prstGeom>
-          <a:noFill/>
-          <a:ln/>
-        </p:spPr>
-        <p:txBody>
-          <a:bodyPr wrap="square" lIns="0" tIns="0" rIns="0" bIns="0" rtlCol="0" anchor="t"/>
-          <a:lstStyle/>
-          <a:p>
-            <a:pPr algn="l" indent="0" marL="0">
-              <a:buNone/>
-            </a:pPr>
-            <a:r>
-              <a:rPr lang="en-US" sz="1300" b="1" dirty="0">
-                <a:solidFill>
-                  <a:srgbClr val="D4461E"/>
-                </a:solidFill>
-                <a:latin typeface="Trebuchet MS" pitchFamily="34" charset="0"/>
-                <a:ea typeface="Trebuchet MS" pitchFamily="34" charset="-122"/>
-                <a:cs typeface="Trebuchet MS" pitchFamily="34" charset="-120"/>
-              </a:rPr>
-              <a:t>边界</a:t>
-            </a:r>
-            <a:endParaRPr lang="en-US" sz="1300" dirty="0"/>
-          </a:p>
-        </p:txBody>
-      </p:sp>
-      <p:sp>
-        <p:nvSpPr>
-          <p:cNvPr id="15" name="Text 12"/>
-          <p:cNvSpPr txBox="1"/>
-          <p:nvPr/>
-        </p:nvSpPr>
-        <p:spPr>
-          <a:xfrm>
-            <a:off x="5468112" y="3645916"/>
-            <a:ext cx="3218688" cy="468884"/>
-          </a:xfrm>
-          <a:prstGeom prst="rect">
-            <a:avLst/>
-          </a:prstGeom>
-          <a:noFill/>
-          <a:ln/>
-        </p:spPr>
-        <p:txBody>
-          <a:bodyPr wrap="square" lIns="0" tIns="0" rIns="0" bIns="0" rtlCol="0" anchor="t">
-            <a:normAutofit/>
-          </a:bodyPr>
-          <a:lstStyle/>
-          <a:p>
-            <a:pPr algn="l" indent="0" marL="0">
-              <a:spcAft>
-                <a:spcPts val="300"/>
-              </a:spcAft>
-              <a:buNone/>
-            </a:pPr>
-            <a:r>
-              <a:rPr lang="en-US" sz="1100" dirty="0">
-                <a:solidFill>
-                  <a:srgbClr val="0A0A0A"/>
-                </a:solidFill>
-                <a:latin typeface="Calibri" pitchFamily="34" charset="0"/>
-                <a:ea typeface="Calibri" pitchFamily="34" charset="-122"/>
-                <a:cs typeface="Calibri" pitchFamily="34" charset="-120"/>
-              </a:rPr>
-              <a:t>74.8 Peta-OPS/W 与 72 ns 使用论文定义口径；不可等同通用数字推理</a:t>
-            </a:r>
-            <a:endParaRPr lang="en-US" sz="1100" dirty="0"/>
-          </a:p>
-        </p:txBody>
-      </p:sp>
-      <p:sp>
-        <p:nvSpPr>
-          <p:cNvPr id="16" name="Text 13"/>
-          <p:cNvSpPr txBox="1"/>
-          <p:nvPr/>
-        </p:nvSpPr>
-        <p:spPr>
-          <a:xfrm>
-            <a:off x="457200" y="4375404"/>
-            <a:ext cx="8229600" cy="201168"/>
-          </a:xfrm>
-          <a:prstGeom prst="rect">
-            <a:avLst/>
-          </a:prstGeom>
-          <a:noFill/>
-          <a:ln/>
-        </p:spPr>
-        <p:txBody>
-          <a:bodyPr wrap="square" lIns="0" tIns="0" rIns="0" bIns="0" rtlCol="0" anchor="t"/>
-          <a:lstStyle/>
-          <a:p>
-            <a:pPr algn="l" indent="0" marL="0">
-              <a:buNone/>
-            </a:pPr>
-            <a:r>
-              <a:rPr lang="en-US" sz="1050" i="1" dirty="0">
-                <a:solidFill>
-                  <a:srgbClr val="6B7280"/>
-                </a:solidFill>
-                <a:latin typeface="Calibri" pitchFamily="34" charset="0"/>
-                <a:ea typeface="Calibri" pitchFamily="34" charset="-122"/>
-                <a:cs typeface="Calibri" pitchFamily="34" charset="-120"/>
-              </a:rPr>
-              <a:t>Chen 等（2023），Nature，Fig. 1(b) 局部；CC BY 4.0。</a:t>
-            </a:r>
-            <a:endParaRPr lang="en-US" sz="1050" dirty="0"/>
-          </a:p>
-        </p:txBody>
-      </p:sp>
-      <p:sp>
-        <p:nvSpPr>
-          <p:cNvPr id="17" name="Shape 14"/>
-          <p:cNvSpPr/>
-          <p:nvPr/>
-        </p:nvSpPr>
-        <p:spPr>
-          <a:xfrm>
-            <a:off x="457200" y="4814316"/>
-            <a:ext cx="8229600" cy="18288"/>
-          </a:xfrm>
-          <a:prstGeom prst="rect">
-            <a:avLst/>
-          </a:prstGeom>
-          <a:solidFill>
-            <a:srgbClr val="E5E7EB"/>
-          </a:solidFill>
-          <a:ln w="12700">
-            <a:solidFill>
-              <a:srgbClr val="FFFFFF"/>
-            </a:solidFill>
-            <a:prstDash val="solid"/>
-          </a:ln>
-        </p:spPr>
-      </p:sp>
-      <p:sp>
-        <p:nvSpPr>
-          <p:cNvPr id="18" name="Text 15"/>
-          <p:cNvSpPr txBox="1"/>
-          <p:nvPr/>
-        </p:nvSpPr>
-        <p:spPr>
-          <a:xfrm>
-            <a:off x="457200" y="4869180"/>
-            <a:ext cx="7580376" cy="274320"/>
-          </a:xfrm>
-          <a:prstGeom prst="rect">
-            <a:avLst/>
-          </a:prstGeom>
-          <a:noFill/>
-          <a:ln/>
-        </p:spPr>
-        <p:txBody>
-          <a:bodyPr wrap="square" lIns="0" tIns="0" rIns="0" bIns="0" rtlCol="0" anchor="ctr">
-            <a:normAutofit/>
-          </a:bodyPr>
-          <a:lstStyle/>
-          <a:p>
-            <a:pPr algn="l" indent="0" marL="0">
-              <a:buNone/>
-            </a:pPr>
-            <a:r>
-              <a:rPr lang="en-US" sz="840" dirty="0">
-                <a:solidFill>
-                  <a:srgbClr val="6B7280"/>
-                </a:solidFill>
-                <a:latin typeface="Calibri" pitchFamily="34" charset="0"/>
-                <a:ea typeface="Calibri" pitchFamily="34" charset="-122"/>
-                <a:cs typeface="Calibri" pitchFamily="34" charset="-120"/>
-              </a:rPr>
-              <a:t>doi:10.1038/s41586-023-06558-8；PMC10620079，Fig. 1(b)</a:t>
-            </a:r>
-            <a:endParaRPr lang="en-US" sz="840" dirty="0"/>
-          </a:p>
-        </p:txBody>
-      </p:sp>
-      <p:sp>
-        <p:nvSpPr>
-          <p:cNvPr id="19" name="Text 16"/>
-          <p:cNvSpPr txBox="1"/>
-          <p:nvPr/>
-        </p:nvSpPr>
-        <p:spPr>
-          <a:xfrm>
-            <a:off x="8183880" y="4869180"/>
-            <a:ext cx="502920" cy="274320"/>
-          </a:xfrm>
-          <a:prstGeom prst="rect">
-            <a:avLst/>
-          </a:prstGeom>
-          <a:noFill/>
-          <a:ln/>
-        </p:spPr>
-        <p:txBody>
-          <a:bodyPr wrap="square" lIns="0" tIns="0" rIns="0" bIns="0" rtlCol="0" anchor="ctr"/>
-          <a:lstStyle/>
-          <a:p>
-            <a:pPr algn="r" indent="0" marL="0">
-              <a:buNone/>
-            </a:pPr>
-            <a:r>
-              <a:rPr lang="en-US" sz="840" dirty="0">
-                <a:solidFill>
-                  <a:srgbClr val="6B7280"/>
-                </a:solidFill>
-                <a:latin typeface="Calibri" pitchFamily="34" charset="0"/>
-                <a:ea typeface="Calibri" pitchFamily="34" charset="-122"/>
-                <a:cs typeface="Calibri" pitchFamily="34" charset="-120"/>
-              </a:rPr>
-              <a:t>9/20</a:t>
-            </a:r>
-            <a:endParaRPr lang="en-US" sz="840" dirty="0"/>
           </a:p>
         </p:txBody>
       </p:sp>

</xml_diff>

<commit_message>
docs: synchronize physics-guided PIC candidate direction preserving user report
</commit_message>
<xml_diff>
--- a/presentations/task-010-group-meeting-rebuild/PIC_Harness_Research_首次组会调研_20页.pptx
+++ b/presentations/task-010-group-meeting-rebuild/PIC_Harness_Research_首次组会调研_20页.pptx
@@ -1313,7 +1313,7 @@
           <a:p>
             <a:r>
               <a:rPr lang="en-US" dirty="0"/>
-              <a:t>PhIDO 与 PICBench 展示结构化表示；AutoPhotonicDesign 展示人类设定约束后的求解器循环；PICopilot 展示脚本评价。值得进一步核验的是复杂物理约束的表达、一致性、跨工具传递与设计过程保持，而不是断言整个领域没有物理约束能力。</a:t>
+              <a:t>当前不是已经定题的路线。PhIDO 与 PICopilot 的评价层级不能证明领域整体缺乏物理决策；AutoPhotonicDesign 已有真实求解器反馈和自主迭代，是最强反例。需要核验可泛化诊断、动作选择和可靠性是否仍有实质缺口。物理推理失败和失败恢复都重要，但不是全部课题。</a:t>
             </a:r>
             <a:endParaRPr lang="en-US" dirty="0"/>
           </a:p>
@@ -1401,7 +1401,7 @@
           <a:p>
             <a:r>
               <a:rPr lang="en-US" dirty="0"/>
-              <a:t>总体目标是让 AI 在专业工具与物理要求支持下参与真实器件/电路设计。当前优先研究设计需求理解和物理约束处理，随后可能延伸到工具执行、仿真反馈与跨任务复用。三个未决问题：已有方法做到何种程度；侧重表达、冲突、传递还是保持；选择什么物理任务验证价值与通用性。</a:t>
+              <a:t>核心问题：Agent 如何利用器件物理与真实仿真反馈做出可靠的下一步决策。DesignSpec 是支持层，Agent 不替代 Maxwell solver；确定性评价器复核达标判断。基础器件推理、1–2 类器件仿真在环和复杂 PIC 只是分层验证概念，尚未确定任务/预算/判据。DAS 只是后续复杂场景候选之一，角色待导师确认。H1诊断缺口、H2可靠性增益、H3相对传统优化/逆设计价值均UNKNOWN。</a:t>
             </a:r>
             <a:endParaRPr lang="en-US" dirty="0"/>
           </a:p>
@@ -5908,7 +5908,7 @@
                 <a:ea typeface="Trebuchet MS" pitchFamily="34" charset="-122"/>
                 <a:cs typeface="Trebuchet MS" pitchFamily="34" charset="-120"/>
               </a:rPr>
-              <a:t>从需求理解到物理验证：约束能否贯穿设计？</a:t>
+              <a:t>从“会调用工具”到“会做物理设计决策”</a:t>
             </a:r>
             <a:endParaRPr lang="en-US" sz="2600" dirty="0"/>
           </a:p>
@@ -5947,7 +5947,7 @@
                 <a:ea typeface="Calibri" pitchFamily="34" charset="-122"/>
                 <a:cs typeface="Calibri" pitchFamily="34" charset="-120"/>
               </a:rPr>
-              <a:t>四层技术问题对应不同论文已有能力和待核证据</a:t>
+              <a:t>候选切入点：器件物理 + 真实仿真反馈支持诊断与下一步动作</a:t>
             </a:r>
             <a:endParaRPr lang="en-US" sz="1300" dirty="0"/>
           </a:p>
@@ -6016,7 +6016,7 @@
                 <a:ea typeface="Calibri" pitchFamily="34" charset="-122"/>
                 <a:cs typeface="Calibri" pitchFamily="34" charset="-120"/>
               </a:rPr>
-              <a:t>依据：PhIDO Fig. 1；PICopilot Fig. 2；AutoPD Fig. 2；PICBench；TASK-007 §研究缺口</a:t>
+              <a:t>候选推断/用户倾向：TASK-007 §6.6；反例：Kharel Fig. 1–6 / Table S2</a:t>
             </a:r>
             <a:endParaRPr lang="en-US" sz="1100" dirty="0"/>
           </a:p>
@@ -6112,7 +6112,7 @@
                 <a:ea typeface="Trebuchet MS" pitchFamily="34" charset="-122"/>
                 <a:cs typeface="Trebuchet MS" pitchFamily="34" charset="-120"/>
               </a:rPr>
-              <a:t>个人倾向：从物理约束理解切入真实 PIC 设计</a:t>
+              <a:t>Physics-guided Autonomous PIC Design</a:t>
             </a:r>
             <a:endParaRPr lang="en-US" sz="2600" dirty="0"/>
           </a:p>
@@ -6151,7 +6151,7 @@
                 <a:ea typeface="Calibri" pitchFamily="34" charset="-122"/>
                 <a:cs typeface="Calibri" pitchFamily="34" charset="-120"/>
               </a:rPr>
-              <a:t>Agentic PIC Design 是主要方向；具体技术方案尚待讨论</a:t>
+              <a:t>物理驱动的自主光子芯片设计｜候选方向，尚待导师确认</a:t>
             </a:r>
             <a:endParaRPr lang="en-US" sz="1300" dirty="0"/>
           </a:p>
@@ -6220,7 +6220,7 @@
                 <a:ea typeface="Calibri" pitchFamily="34" charset="-122"/>
                 <a:cs typeface="Calibri" pitchFamily="34" charset="-120"/>
               </a:rPr>
-              <a:t>来源：用户确认的个人倾向；TASK-007 候选路线仅作背景</a:t>
+              <a:t>来源：2026-09-30 用户候选方向；TASK-007 §6.6；概念图非已实现系统</a:t>
             </a:r>
             <a:endParaRPr lang="en-US" sz="1100" dirty="0"/>
           </a:p>
@@ -6683,7 +6683,7 @@
                 <a:ea typeface="Calibri" pitchFamily="34" charset="-122"/>
                 <a:cs typeface="Calibri" pitchFamily="34" charset="-120"/>
               </a:rPr>
-              <a:t>个人倾向优先关注需求理解与物理约束处理</a:t>
+              <a:t>当前候选倾向：物理引导的设计诊断与决策</a:t>
             </a:r>
             <a:endParaRPr lang="en-US" sz="1400" dirty="0"/>
           </a:p>
@@ -6765,7 +6765,7 @@
                 <a:ea typeface="Calibri" pitchFamily="34" charset="-122"/>
                 <a:cs typeface="Calibri" pitchFamily="34" charset="-120"/>
               </a:rPr>
-              <a:t>是否适合优先深入 PIC 设计需求与物理约束处理？</a:t>
+              <a:t>相对求解器闭环与传统优化，诊断决策有何增量价值？</a:t>
             </a:r>
             <a:endParaRPr lang="en-US" sz="1400" dirty="0"/>
           </a:p>
@@ -6786,7 +6786,7 @@
                 <a:ea typeface="Calibri" pitchFamily="34" charset="-122"/>
                 <a:cs typeface="Calibri" pitchFamily="34" charset="-120"/>
               </a:rPr>
-              <a:t>下一阶段聚焦哪些具体技术问题和代表工作，才能明确研究贡献？</a:t>
+              <a:t>DAS 最终角色与系统边界如何确定？</a:t>
             </a:r>
             <a:endParaRPr lang="en-US" sz="1400" dirty="0"/>
           </a:p>
@@ -6966,7 +6966,7 @@
                 <a:ea typeface="Calibri" pitchFamily="34" charset="-122"/>
                 <a:cs typeface="Calibri" pitchFamily="34" charset="-120"/>
               </a:rPr>
-              <a:t>来源：TASK-007 正式报告与候选路线；用户确认的最新研究倾向 · Sources: TASK-007 正式报告与候选路线；用户确认的最新研究倾向</a:t>
+              <a:t>TASK-007 §6.6；用户候选倾向，尚待确认 · Sources: TASK-007 §6.6；用户候选倾向</a:t>
             </a:r>
             <a:endParaRPr lang="en-US" sz="840" dirty="0"/>
           </a:p>

</xml_diff>